<commit_message>
Render tab stops, Office line spacing and rectangular path gradients
- Custom tab stops (left/centre/right/decimal, hanging indent) are laid out
  by the runtime from data attributes; static pages fall back to tab-size
- Line spacing above single and exact spacing give a fixed line pitch with
  the extra space above the text, as Office and LibreOffice do (exact
  spacing was taller than requested because of the paragraph strut)
- Rectangular / shape path gradients use equidistant edge bands converging
  on fillToRect instead of an elliptical approximation
- Verifier: in-page 'eval' checks, list screenshots include the player,
  LibreOffice references are cached between runs; snap tool uses the player

Co-Authored-By: Claude Opus 5.5 <noreply@anthropic.com>
Claude-Session: https://claude.ai/code/session_015A8MAHWzu7DP7mvmPJpYQv
</commit_message>
<xml_diff>
--- a/samples/features/text.pptx
+++ b/samples/features/text.pptx
@@ -3438,6 +3438,48 @@
           </a:p>
         </p:txBody>
       </p:sp>
+      <p:sp>
+        <p:nvSpPr>
+          <p:cNvPr id="9" name="tab stops"/>
+          <p:cNvSpPr/>
+          <p:nvPr/>
+        </p:nvSpPr>
+        <p:spPr>
+          <a:xfrm>
+            <a:off x="6477000" y="4191000"/>
+            <a:ext cx="5334000" cy="1143000"/>
+          </a:xfrm>
+          <a:prstGeom prst="rect">
+            <a:avLst/>
+          </a:prstGeom>
+          <a:solidFill>
+            <a:srgbClr val="F2F2F2"/>
+          </a:solidFill>
+          <a:ln w="9525">
+            <a:solidFill>
+              <a:srgbClr val="A6A6A6"/>
+            </a:solidFill>
+          </a:ln>
+        </p:spPr>
+        <p:txBody>
+          <a:bodyPr anchor="t"/>
+          <a:lstStyle/>
+          <a:p>
+            <a:pPr>
+              <a:tabLst>
+                <a:tab pos="1371600" algn="l"/>
+                <a:tab pos="2743200" algn="ctr"/>
+                <a:tab pos="4572000" algn="r"/>
+              </a:tabLst>
+            </a:pPr>
+            <a:r>
+              <a:rPr lang="en-US" dirty="0" sz="1600"/>
+              <a:t>Left	Stop	Centre	Right</a:t>
+            </a:r>
+            <a:endParaRPr lang="en-US" dirty="0"/>
+          </a:p>
+        </p:txBody>
+      </p:sp>
     </p:spTree>
   </p:cSld>
   <p:clrMapOvr>

</xml_diff>

<commit_message>
Render WordArt transforms (prstTxWarp)
- Compile the 40 ECMA-376 text warp presets (presetTextWarpDefinitions.xml)
  alongside the shape presets; the renderer emits each warp's paths over
  the text rectangle as polylines
- The runtime splits warped text into glyphs and maps each with an affine
  transform: warp presets stretch the ink of each line between pairs of
  paths; follow-path presets (arches, circle, button) keep glyph sizes and
  run the text along the inner side of the path
- Fixture slide with 16 warps, verified against LibreOffice

Co-Authored-By: Claude Opus 5.5 <noreply@anthropic.com>
Claude-Session: https://claude.ai/code/session_015A8MAHWzu7DP7mvmPJpYQv
</commit_message>
<xml_diff>
--- a/samples/features/text.pptx
+++ b/samples/features/text.pptx
@@ -12,6 +12,7 @@
     <p:sldId id="260" r:id="rId14"/>
     <p:sldId id="261" r:id="rId15"/>
     <p:sldId id="262" r:id="rId16"/>
+    <p:sldId id="263" r:id="rId17"/>
   </p:sldIdLst>
   <p:sldSz cx="12192000" cy="6858000"/>
   <p:notesSz cx="6858000" cy="9144000"/>
@@ -4247,6 +4248,753 @@
                 </a:solidFill>
               </a:rPr>
               <a:t>Arch up WordArt</a:t>
+            </a:r>
+            <a:endParaRPr lang="en-US" dirty="0"/>
+          </a:p>
+        </p:txBody>
+      </p:sp>
+    </p:spTree>
+  </p:cSld>
+  <p:clrMapOvr>
+    <a:masterClrMapping/>
+  </p:clrMapOvr>
+</p:sld>
+</file>
+
+<file path=ppt/slides/slide8.xml><?xml version="1.0" encoding="utf-8"?>
+<p:sld xmlns:a="http://schemas.openxmlformats.org/drawingml/2006/main" xmlns:r="http://schemas.openxmlformats.org/officeDocument/2006/relationships" xmlns:p="http://schemas.openxmlformats.org/presentationml/2006/main" xmlns:mc="http://schemas.openxmlformats.org/markup-compatibility/2006" xmlns:p14="http://schemas.microsoft.com/office/powerpoint/2010/main" xmlns:p15="http://schemas.microsoft.com/office/powerpoint/2012/main" xmlns:a14="http://schemas.microsoft.com/office/drawing/2010/main" xmlns:p159="http://schemas.microsoft.com/office/powerpoint/2015/09/main">
+  <p:cSld name="WordArt warps">
+    <p:spTree>
+      <p:nvGrpSpPr>
+        <p:cNvPr id="1" name=""/>
+        <p:cNvGrpSpPr/>
+        <p:nvPr/>
+      </p:nvGrpSpPr>
+      <p:grpSpPr>
+        <a:xfrm>
+          <a:off x="0" y="0"/>
+          <a:ext cx="0" cy="0"/>
+          <a:chOff x="0" y="0"/>
+          <a:chExt cx="0" cy="0"/>
+        </a:xfrm>
+      </p:grpSpPr>
+      <p:sp>
+        <p:nvSpPr>
+          <p:cNvPr id="2" name="Label"/>
+          <p:cNvSpPr txBox="1"/>
+          <p:nvPr/>
+        </p:nvSpPr>
+        <p:spPr>
+          <a:xfrm>
+            <a:off x="190500" y="76200"/>
+            <a:ext cx="11811000" cy="381000"/>
+          </a:xfrm>
+          <a:prstGeom prst="rect">
+            <a:avLst/>
+          </a:prstGeom>
+          <a:noFill/>
+        </p:spPr>
+        <p:txBody>
+          <a:bodyPr wrap="square" rtlCol="0">
+            <a:spAutoFit/>
+          </a:bodyPr>
+          <a:lstStyle/>
+          <a:p>
+            <a:r>
+              <a:rPr lang="en-US" dirty="0" sz="2000" b="1"/>
+              <a:t>WordArt transforms: arch, circle, button, wave, inflate, deflate, slant, triangle, chevron, can, fade, cascade, ring, plain</a:t>
+            </a:r>
+            <a:endParaRPr lang="en-US" dirty="0"/>
+          </a:p>
+        </p:txBody>
+      </p:sp>
+      <p:sp>
+        <p:nvSpPr>
+          <p:cNvPr id="3" name="textArchUp"/>
+          <p:cNvSpPr/>
+          <p:nvPr/>
+        </p:nvSpPr>
+        <p:spPr>
+          <a:xfrm>
+            <a:off x="285750" y="666750"/>
+            <a:ext cx="2667000" cy="1238250"/>
+          </a:xfrm>
+          <a:prstGeom prst="rect">
+            <a:avLst/>
+          </a:prstGeom>
+          <a:noFill/>
+          <a:ln>
+            <a:noFill/>
+          </a:ln>
+        </p:spPr>
+        <p:txBody>
+          <a:bodyPr wrap="none" lIns="0" tIns="0" rIns="0" bIns="0" anchor="ctr">
+            <a:prstTxWarp prst="textArchUp">
+              <a:avLst/>
+            </a:prstTxWarp>
+            <a:noAutofit/>
+          </a:bodyPr>
+          <a:lstStyle/>
+          <a:p>
+            <a:pPr algn="ctr"/>
+            <a:r>
+              <a:rPr lang="en-US" dirty="0" sz="3200" b="1">
+                <a:solidFill>
+                  <a:srgbClr val="C00000"/>
+                </a:solidFill>
+              </a:rPr>
+              <a:t>WordArt</a:t>
+            </a:r>
+            <a:endParaRPr lang="en-US" dirty="0"/>
+          </a:p>
+        </p:txBody>
+      </p:sp>
+      <p:sp>
+        <p:nvSpPr>
+          <p:cNvPr id="4" name="textArchDown"/>
+          <p:cNvSpPr/>
+          <p:nvPr/>
+        </p:nvSpPr>
+        <p:spPr>
+          <a:xfrm>
+            <a:off x="3238500" y="666750"/>
+            <a:ext cx="2667000" cy="1238250"/>
+          </a:xfrm>
+          <a:prstGeom prst="rect">
+            <a:avLst/>
+          </a:prstGeom>
+          <a:noFill/>
+          <a:ln>
+            <a:noFill/>
+          </a:ln>
+        </p:spPr>
+        <p:txBody>
+          <a:bodyPr wrap="none" lIns="0" tIns="0" rIns="0" bIns="0" anchor="ctr">
+            <a:prstTxWarp prst="textArchDown">
+              <a:avLst/>
+            </a:prstTxWarp>
+            <a:noAutofit/>
+          </a:bodyPr>
+          <a:lstStyle/>
+          <a:p>
+            <a:pPr algn="ctr"/>
+            <a:r>
+              <a:rPr lang="en-US" dirty="0" sz="3200" b="1">
+                <a:solidFill>
+                  <a:srgbClr val="0070C0"/>
+                </a:solidFill>
+              </a:rPr>
+              <a:t>WordArt</a:t>
+            </a:r>
+            <a:endParaRPr lang="en-US" dirty="0"/>
+          </a:p>
+        </p:txBody>
+      </p:sp>
+      <p:sp>
+        <p:nvSpPr>
+          <p:cNvPr id="5" name="textCircle"/>
+          <p:cNvSpPr/>
+          <p:nvPr/>
+        </p:nvSpPr>
+        <p:spPr>
+          <a:xfrm>
+            <a:off x="6191250" y="666750"/>
+            <a:ext cx="2667000" cy="1238250"/>
+          </a:xfrm>
+          <a:prstGeom prst="rect">
+            <a:avLst/>
+          </a:prstGeom>
+          <a:noFill/>
+          <a:ln>
+            <a:noFill/>
+          </a:ln>
+        </p:spPr>
+        <p:txBody>
+          <a:bodyPr wrap="none" lIns="0" tIns="0" rIns="0" bIns="0" anchor="ctr">
+            <a:prstTxWarp prst="textCircle">
+              <a:avLst/>
+            </a:prstTxWarp>
+            <a:noAutofit/>
+          </a:bodyPr>
+          <a:lstStyle/>
+          <a:p>
+            <a:pPr algn="ctr"/>
+            <a:r>
+              <a:rPr lang="en-US" dirty="0" sz="3200" b="1">
+                <a:solidFill>
+                  <a:srgbClr val="00B050"/>
+                </a:solidFill>
+              </a:rPr>
+              <a:t>WordArt</a:t>
+            </a:r>
+            <a:endParaRPr lang="en-US" dirty="0"/>
+          </a:p>
+        </p:txBody>
+      </p:sp>
+      <p:sp>
+        <p:nvSpPr>
+          <p:cNvPr id="6" name="textButton"/>
+          <p:cNvSpPr/>
+          <p:nvPr/>
+        </p:nvSpPr>
+        <p:spPr>
+          <a:xfrm>
+            <a:off x="9144000" y="666750"/>
+            <a:ext cx="2667000" cy="1238250"/>
+          </a:xfrm>
+          <a:prstGeom prst="rect">
+            <a:avLst/>
+          </a:prstGeom>
+          <a:noFill/>
+          <a:ln>
+            <a:noFill/>
+          </a:ln>
+        </p:spPr>
+        <p:txBody>
+          <a:bodyPr wrap="none" lIns="0" tIns="0" rIns="0" bIns="0" anchor="ctr">
+            <a:prstTxWarp prst="textButton">
+              <a:avLst/>
+            </a:prstTxWarp>
+            <a:noAutofit/>
+          </a:bodyPr>
+          <a:lstStyle/>
+          <a:p>
+            <a:pPr algn="ctr"/>
+            <a:r>
+              <a:rPr lang="en-US" dirty="0" sz="3200" b="1">
+                <a:solidFill>
+                  <a:srgbClr val="7030A0"/>
+                </a:solidFill>
+              </a:rPr>
+              <a:t>Word</a:t>
+            </a:r>
+            <a:endParaRPr lang="en-US" dirty="0"/>
+          </a:p>
+          <a:p>
+            <a:pPr algn="ctr"/>
+            <a:r>
+              <a:rPr lang="en-US" dirty="0" sz="3200" b="1">
+                <a:solidFill>
+                  <a:srgbClr val="7030A0"/>
+                </a:solidFill>
+              </a:rPr>
+              <a:t>Art</a:t>
+            </a:r>
+            <a:endParaRPr lang="en-US" dirty="0"/>
+          </a:p>
+          <a:p>
+            <a:pPr algn="ctr"/>
+            <a:r>
+              <a:rPr lang="en-US" dirty="0" sz="3200" b="1">
+                <a:solidFill>
+                  <a:srgbClr val="7030A0"/>
+                </a:solidFill>
+              </a:rPr>
+              <a:t>Text</a:t>
+            </a:r>
+            <a:endParaRPr lang="en-US" dirty="0"/>
+          </a:p>
+        </p:txBody>
+      </p:sp>
+      <p:sp>
+        <p:nvSpPr>
+          <p:cNvPr id="7" name="textWave1"/>
+          <p:cNvSpPr/>
+          <p:nvPr/>
+        </p:nvSpPr>
+        <p:spPr>
+          <a:xfrm>
+            <a:off x="285750" y="2190750"/>
+            <a:ext cx="2667000" cy="1238250"/>
+          </a:xfrm>
+          <a:prstGeom prst="rect">
+            <a:avLst/>
+          </a:prstGeom>
+          <a:noFill/>
+          <a:ln>
+            <a:noFill/>
+          </a:ln>
+        </p:spPr>
+        <p:txBody>
+          <a:bodyPr wrap="none" lIns="0" tIns="0" rIns="0" bIns="0" anchor="ctr">
+            <a:prstTxWarp prst="textWave1">
+              <a:avLst/>
+            </a:prstTxWarp>
+            <a:noAutofit/>
+          </a:bodyPr>
+          <a:lstStyle/>
+          <a:p>
+            <a:pPr algn="ctr"/>
+            <a:r>
+              <a:rPr lang="en-US" dirty="0" sz="3200" b="1">
+                <a:solidFill>
+                  <a:srgbClr val="C00000"/>
+                </a:solidFill>
+              </a:rPr>
+              <a:t>WordArt</a:t>
+            </a:r>
+            <a:endParaRPr lang="en-US" dirty="0"/>
+          </a:p>
+        </p:txBody>
+      </p:sp>
+      <p:sp>
+        <p:nvSpPr>
+          <p:cNvPr id="8" name="textInflate"/>
+          <p:cNvSpPr/>
+          <p:nvPr/>
+        </p:nvSpPr>
+        <p:spPr>
+          <a:xfrm>
+            <a:off x="3238500" y="2190750"/>
+            <a:ext cx="2667000" cy="1238250"/>
+          </a:xfrm>
+          <a:prstGeom prst="rect">
+            <a:avLst/>
+          </a:prstGeom>
+          <a:noFill/>
+          <a:ln>
+            <a:noFill/>
+          </a:ln>
+        </p:spPr>
+        <p:txBody>
+          <a:bodyPr wrap="none" lIns="0" tIns="0" rIns="0" bIns="0" anchor="ctr">
+            <a:prstTxWarp prst="textInflate">
+              <a:avLst/>
+            </a:prstTxWarp>
+            <a:noAutofit/>
+          </a:bodyPr>
+          <a:lstStyle/>
+          <a:p>
+            <a:pPr algn="ctr"/>
+            <a:r>
+              <a:rPr lang="en-US" dirty="0" sz="3200" b="1">
+                <a:solidFill>
+                  <a:srgbClr val="0070C0"/>
+                </a:solidFill>
+              </a:rPr>
+              <a:t>WordArt</a:t>
+            </a:r>
+            <a:endParaRPr lang="en-US" dirty="0"/>
+          </a:p>
+        </p:txBody>
+      </p:sp>
+      <p:sp>
+        <p:nvSpPr>
+          <p:cNvPr id="9" name="textDeflate"/>
+          <p:cNvSpPr/>
+          <p:nvPr/>
+        </p:nvSpPr>
+        <p:spPr>
+          <a:xfrm>
+            <a:off x="6191250" y="2190750"/>
+            <a:ext cx="2667000" cy="1238250"/>
+          </a:xfrm>
+          <a:prstGeom prst="rect">
+            <a:avLst/>
+          </a:prstGeom>
+          <a:noFill/>
+          <a:ln>
+            <a:noFill/>
+          </a:ln>
+        </p:spPr>
+        <p:txBody>
+          <a:bodyPr wrap="none" lIns="0" tIns="0" rIns="0" bIns="0" anchor="ctr">
+            <a:prstTxWarp prst="textDeflate">
+              <a:avLst/>
+            </a:prstTxWarp>
+            <a:noAutofit/>
+          </a:bodyPr>
+          <a:lstStyle/>
+          <a:p>
+            <a:pPr algn="ctr"/>
+            <a:r>
+              <a:rPr lang="en-US" dirty="0" sz="3200" b="1">
+                <a:solidFill>
+                  <a:srgbClr val="00B050"/>
+                </a:solidFill>
+              </a:rPr>
+              <a:t>WordArt</a:t>
+            </a:r>
+            <a:endParaRPr lang="en-US" dirty="0"/>
+          </a:p>
+        </p:txBody>
+      </p:sp>
+      <p:sp>
+        <p:nvSpPr>
+          <p:cNvPr id="10" name="textSlantUp"/>
+          <p:cNvSpPr/>
+          <p:nvPr/>
+        </p:nvSpPr>
+        <p:spPr>
+          <a:xfrm>
+            <a:off x="9144000" y="2190750"/>
+            <a:ext cx="2667000" cy="1238250"/>
+          </a:xfrm>
+          <a:prstGeom prst="rect">
+            <a:avLst/>
+          </a:prstGeom>
+          <a:noFill/>
+          <a:ln>
+            <a:noFill/>
+          </a:ln>
+        </p:spPr>
+        <p:txBody>
+          <a:bodyPr wrap="none" lIns="0" tIns="0" rIns="0" bIns="0" anchor="ctr">
+            <a:prstTxWarp prst="textSlantUp">
+              <a:avLst/>
+            </a:prstTxWarp>
+            <a:noAutofit/>
+          </a:bodyPr>
+          <a:lstStyle/>
+          <a:p>
+            <a:pPr algn="ctr"/>
+            <a:r>
+              <a:rPr lang="en-US" dirty="0" sz="3200" b="1">
+                <a:solidFill>
+                  <a:srgbClr val="7030A0"/>
+                </a:solidFill>
+              </a:rPr>
+              <a:t>WordArt</a:t>
+            </a:r>
+            <a:endParaRPr lang="en-US" dirty="0"/>
+          </a:p>
+        </p:txBody>
+      </p:sp>
+      <p:sp>
+        <p:nvSpPr>
+          <p:cNvPr id="11" name="textTriangle"/>
+          <p:cNvSpPr/>
+          <p:nvPr/>
+        </p:nvSpPr>
+        <p:spPr>
+          <a:xfrm>
+            <a:off x="285750" y="3714750"/>
+            <a:ext cx="2667000" cy="1238250"/>
+          </a:xfrm>
+          <a:prstGeom prst="rect">
+            <a:avLst/>
+          </a:prstGeom>
+          <a:noFill/>
+          <a:ln>
+            <a:noFill/>
+          </a:ln>
+        </p:spPr>
+        <p:txBody>
+          <a:bodyPr wrap="none" lIns="0" tIns="0" rIns="0" bIns="0" anchor="ctr">
+            <a:prstTxWarp prst="textTriangle">
+              <a:avLst/>
+            </a:prstTxWarp>
+            <a:noAutofit/>
+          </a:bodyPr>
+          <a:lstStyle/>
+          <a:p>
+            <a:pPr algn="ctr"/>
+            <a:r>
+              <a:rPr lang="en-US" dirty="0" sz="3200" b="1">
+                <a:solidFill>
+                  <a:srgbClr val="C00000"/>
+                </a:solidFill>
+              </a:rPr>
+              <a:t>WordArt</a:t>
+            </a:r>
+            <a:endParaRPr lang="en-US" dirty="0"/>
+          </a:p>
+        </p:txBody>
+      </p:sp>
+      <p:sp>
+        <p:nvSpPr>
+          <p:cNvPr id="12" name="textChevron"/>
+          <p:cNvSpPr/>
+          <p:nvPr/>
+        </p:nvSpPr>
+        <p:spPr>
+          <a:xfrm>
+            <a:off x="3238500" y="3714750"/>
+            <a:ext cx="2667000" cy="1238250"/>
+          </a:xfrm>
+          <a:prstGeom prst="rect">
+            <a:avLst/>
+          </a:prstGeom>
+          <a:noFill/>
+          <a:ln>
+            <a:noFill/>
+          </a:ln>
+        </p:spPr>
+        <p:txBody>
+          <a:bodyPr wrap="none" lIns="0" tIns="0" rIns="0" bIns="0" anchor="ctr">
+            <a:prstTxWarp prst="textChevron">
+              <a:avLst/>
+            </a:prstTxWarp>
+            <a:noAutofit/>
+          </a:bodyPr>
+          <a:lstStyle/>
+          <a:p>
+            <a:pPr algn="ctr"/>
+            <a:r>
+              <a:rPr lang="en-US" dirty="0" sz="3200" b="1">
+                <a:solidFill>
+                  <a:srgbClr val="0070C0"/>
+                </a:solidFill>
+              </a:rPr>
+              <a:t>WordArt</a:t>
+            </a:r>
+            <a:endParaRPr lang="en-US" dirty="0"/>
+          </a:p>
+        </p:txBody>
+      </p:sp>
+      <p:sp>
+        <p:nvSpPr>
+          <p:cNvPr id="13" name="textCanUp"/>
+          <p:cNvSpPr/>
+          <p:nvPr/>
+        </p:nvSpPr>
+        <p:spPr>
+          <a:xfrm>
+            <a:off x="6191250" y="3714750"/>
+            <a:ext cx="2667000" cy="1238250"/>
+          </a:xfrm>
+          <a:prstGeom prst="rect">
+            <a:avLst/>
+          </a:prstGeom>
+          <a:noFill/>
+          <a:ln>
+            <a:noFill/>
+          </a:ln>
+        </p:spPr>
+        <p:txBody>
+          <a:bodyPr wrap="none" lIns="0" tIns="0" rIns="0" bIns="0" anchor="ctr">
+            <a:prstTxWarp prst="textCanUp">
+              <a:avLst/>
+            </a:prstTxWarp>
+            <a:noAutofit/>
+          </a:bodyPr>
+          <a:lstStyle/>
+          <a:p>
+            <a:pPr algn="ctr"/>
+            <a:r>
+              <a:rPr lang="en-US" dirty="0" sz="3200" b="1">
+                <a:solidFill>
+                  <a:srgbClr val="00B050"/>
+                </a:solidFill>
+              </a:rPr>
+              <a:t>WordArt</a:t>
+            </a:r>
+            <a:endParaRPr lang="en-US" dirty="0"/>
+          </a:p>
+        </p:txBody>
+      </p:sp>
+      <p:sp>
+        <p:nvSpPr>
+          <p:cNvPr id="14" name="textFadeRight"/>
+          <p:cNvSpPr/>
+          <p:nvPr/>
+        </p:nvSpPr>
+        <p:spPr>
+          <a:xfrm>
+            <a:off x="9144000" y="3714750"/>
+            <a:ext cx="2667000" cy="1238250"/>
+          </a:xfrm>
+          <a:prstGeom prst="rect">
+            <a:avLst/>
+          </a:prstGeom>
+          <a:noFill/>
+          <a:ln>
+            <a:noFill/>
+          </a:ln>
+        </p:spPr>
+        <p:txBody>
+          <a:bodyPr wrap="none" lIns="0" tIns="0" rIns="0" bIns="0" anchor="ctr">
+            <a:prstTxWarp prst="textFadeRight">
+              <a:avLst/>
+            </a:prstTxWarp>
+            <a:noAutofit/>
+          </a:bodyPr>
+          <a:lstStyle/>
+          <a:p>
+            <a:pPr algn="ctr"/>
+            <a:r>
+              <a:rPr lang="en-US" dirty="0" sz="3200" b="1">
+                <a:solidFill>
+                  <a:srgbClr val="7030A0"/>
+                </a:solidFill>
+              </a:rPr>
+              <a:t>WordArt</a:t>
+            </a:r>
+            <a:endParaRPr lang="en-US" dirty="0"/>
+          </a:p>
+        </p:txBody>
+      </p:sp>
+      <p:sp>
+        <p:nvSpPr>
+          <p:cNvPr id="15" name="textCascadeUp"/>
+          <p:cNvSpPr/>
+          <p:nvPr/>
+        </p:nvSpPr>
+        <p:spPr>
+          <a:xfrm>
+            <a:off x="285750" y="5238750"/>
+            <a:ext cx="2667000" cy="1238250"/>
+          </a:xfrm>
+          <a:prstGeom prst="rect">
+            <a:avLst/>
+          </a:prstGeom>
+          <a:noFill/>
+          <a:ln>
+            <a:noFill/>
+          </a:ln>
+        </p:spPr>
+        <p:txBody>
+          <a:bodyPr wrap="none" lIns="0" tIns="0" rIns="0" bIns="0" anchor="ctr">
+            <a:prstTxWarp prst="textCascadeUp">
+              <a:avLst/>
+            </a:prstTxWarp>
+            <a:noAutofit/>
+          </a:bodyPr>
+          <a:lstStyle/>
+          <a:p>
+            <a:pPr algn="ctr"/>
+            <a:r>
+              <a:rPr lang="en-US" dirty="0" sz="3200" b="1">
+                <a:solidFill>
+                  <a:srgbClr val="C00000"/>
+                </a:solidFill>
+              </a:rPr>
+              <a:t>WordArt</a:t>
+            </a:r>
+            <a:endParaRPr lang="en-US" dirty="0"/>
+          </a:p>
+        </p:txBody>
+      </p:sp>
+      <p:sp>
+        <p:nvSpPr>
+          <p:cNvPr id="16" name="textRingInside"/>
+          <p:cNvSpPr/>
+          <p:nvPr/>
+        </p:nvSpPr>
+        <p:spPr>
+          <a:xfrm>
+            <a:off x="3238500" y="5238750"/>
+            <a:ext cx="2667000" cy="1238250"/>
+          </a:xfrm>
+          <a:prstGeom prst="rect">
+            <a:avLst/>
+          </a:prstGeom>
+          <a:noFill/>
+          <a:ln>
+            <a:noFill/>
+          </a:ln>
+        </p:spPr>
+        <p:txBody>
+          <a:bodyPr wrap="none" lIns="0" tIns="0" rIns="0" bIns="0" anchor="ctr">
+            <a:prstTxWarp prst="textRingInside">
+              <a:avLst/>
+            </a:prstTxWarp>
+            <a:noAutofit/>
+          </a:bodyPr>
+          <a:lstStyle/>
+          <a:p>
+            <a:pPr algn="ctr"/>
+            <a:r>
+              <a:rPr lang="en-US" dirty="0" sz="3200" b="1">
+                <a:solidFill>
+                  <a:srgbClr val="0070C0"/>
+                </a:solidFill>
+              </a:rPr>
+              <a:t>WordArt</a:t>
+            </a:r>
+            <a:endParaRPr lang="en-US" dirty="0"/>
+          </a:p>
+        </p:txBody>
+      </p:sp>
+      <p:sp>
+        <p:nvSpPr>
+          <p:cNvPr id="17" name="textDeflateInflate"/>
+          <p:cNvSpPr/>
+          <p:nvPr/>
+        </p:nvSpPr>
+        <p:spPr>
+          <a:xfrm>
+            <a:off x="6191250" y="5238750"/>
+            <a:ext cx="2667000" cy="1238250"/>
+          </a:xfrm>
+          <a:prstGeom prst="rect">
+            <a:avLst/>
+          </a:prstGeom>
+          <a:noFill/>
+          <a:ln>
+            <a:noFill/>
+          </a:ln>
+        </p:spPr>
+        <p:txBody>
+          <a:bodyPr wrap="none" lIns="0" tIns="0" rIns="0" bIns="0" anchor="ctr">
+            <a:prstTxWarp prst="textDeflateInflate">
+              <a:avLst/>
+            </a:prstTxWarp>
+            <a:noAutofit/>
+          </a:bodyPr>
+          <a:lstStyle/>
+          <a:p>
+            <a:pPr algn="ctr"/>
+            <a:r>
+              <a:rPr lang="en-US" dirty="0" sz="3200" b="1">
+                <a:solidFill>
+                  <a:srgbClr val="00B050"/>
+                </a:solidFill>
+              </a:rPr>
+              <a:t>Word</a:t>
+            </a:r>
+            <a:endParaRPr lang="en-US" dirty="0"/>
+          </a:p>
+          <a:p>
+            <a:pPr algn="ctr"/>
+            <a:r>
+              <a:rPr lang="en-US" dirty="0" sz="3200" b="1">
+                <a:solidFill>
+                  <a:srgbClr val="00B050"/>
+                </a:solidFill>
+              </a:rPr>
+              <a:t>Art</a:t>
+            </a:r>
+            <a:endParaRPr lang="en-US" dirty="0"/>
+          </a:p>
+        </p:txBody>
+      </p:sp>
+      <p:sp>
+        <p:nvSpPr>
+          <p:cNvPr id="18" name="textPlain"/>
+          <p:cNvSpPr/>
+          <p:nvPr/>
+        </p:nvSpPr>
+        <p:spPr>
+          <a:xfrm>
+            <a:off x="9144000" y="5238750"/>
+            <a:ext cx="2667000" cy="1238250"/>
+          </a:xfrm>
+          <a:prstGeom prst="rect">
+            <a:avLst/>
+          </a:prstGeom>
+          <a:noFill/>
+          <a:ln>
+            <a:noFill/>
+          </a:ln>
+        </p:spPr>
+        <p:txBody>
+          <a:bodyPr wrap="none" lIns="0" tIns="0" rIns="0" bIns="0" anchor="ctr">
+            <a:prstTxWarp prst="textPlain">
+              <a:avLst/>
+            </a:prstTxWarp>
+            <a:noAutofit/>
+          </a:bodyPr>
+          <a:lstStyle/>
+          <a:p>
+            <a:pPr algn="ctr"/>
+            <a:r>
+              <a:rPr lang="en-US" dirty="0" sz="3200" b="1">
+                <a:solidFill>
+                  <a:srgbClr val="7030A0"/>
+                </a:solidFill>
+              </a:rPr>
+              <a:t>WordArt</a:t>
             </a:r>
             <a:endParaRPr lang="en-US" dirty="0"/>
           </a:p>

</xml_diff>

<commit_message>
Shrink auto-fitting text at runtime; use OLE fallback pictures
- normAutofit / spAutoFit text bodies get scalable font sizes (CSS
  variable); the runtime shrinks text that overflows its box because a
  substituted font is wider than the original
- OLE objects in mc:AlternateContent take the branch with a preview
  picture (the VML branch has none)
- Fixture check for the runtime fit; README lists src/smartart and the
  SmartArt oracle

Co-Authored-By: Claude Opus 5.5 <noreply@anthropic.com>
Claude-Session: https://claude.ai/code/session_015A8MAHWzu7DP7mvmPJpYQv
</commit_message>
<xml_diff>
--- a/samples/features/text.pptx
+++ b/samples/features/text.pptx
@@ -3481,6 +3481,43 @@
           </a:p>
         </p:txBody>
       </p:sp>
+      <p:sp>
+        <p:nvSpPr>
+          <p:cNvPr id="10" name="autofit"/>
+          <p:cNvSpPr/>
+          <p:nvPr/>
+        </p:nvSpPr>
+        <p:spPr>
+          <a:xfrm>
+            <a:off x="9525000" y="5524500"/>
+            <a:ext cx="2286000" cy="952500"/>
+          </a:xfrm>
+          <a:prstGeom prst="rect">
+            <a:avLst/>
+          </a:prstGeom>
+          <a:solidFill>
+            <a:srgbClr val="F2F2F2"/>
+          </a:solidFill>
+          <a:ln w="9525">
+            <a:solidFill>
+              <a:srgbClr val="A6A6A6"/>
+            </a:solidFill>
+          </a:ln>
+        </p:spPr>
+        <p:txBody>
+          <a:bodyPr anchor="t">
+            <a:normAutofit/>
+          </a:bodyPr>
+          <a:lstStyle/>
+          <a:p>
+            <a:r>
+              <a:rPr lang="en-US" dirty="0" sz="2400"/>
+              <a:t>Shrink this text so that it fits inside its box</a:t>
+            </a:r>
+            <a:endParaRPr lang="en-US" dirty="0"/>
+          </a:p>
+        </p:txBody>
+      </p:sp>
     </p:spTree>
   </p:cSld>
   <p:clrMapOvr>

</xml_diff>